<commit_message>
PPT slide 3: add DB analysis box under Langflow layer
3-Layer 아키텍처의 2번째(Langflow) 레이어 하단에 별도 box 추가:
- 'DB 분석 · 차트 선택' + 'scatter · box · pie · histogram'
- 패널 하단에서 내려오는 연결 표시(▼), 딥틸 강조 테두리
- python-pptx로 기존 서식(Arial/딥틸 0F9D8F)에 맞춰 삽입, 7개 슬라이드 보존

Co-Authored-By: Claude Opus 4.8 <noreply@anthropic.com>
Claude-Session: https://claude.ai/code/session_017j13vZbd8GoEdjrSJmwL2Z
</commit_message>
<xml_diff>
--- a/eom_analyzer/docs/PAM4_EOM_Agent_Overview.pptx
+++ b/eom_analyzer/docs/PAM4_EOM_Agent_Overview.pptx
@@ -4718,6 +4718,110 @@
               <a:t>created_at</a:t>
             </a:r>
             <a:endParaRPr lang="en-US" sz="950" dirty="0"/>
+          </a:p>
+        </p:txBody>
+      </p:sp>
+      <p:sp>
+        <p:nvSpPr>
+          <p:cNvPr id="30" name="DB Analysis Box"/>
+          <p:cNvSpPr/>
+          <p:nvPr/>
+        </p:nvSpPr>
+        <p:spPr>
+          <a:xfrm>
+            <a:off x="3383280" y="4632000"/>
+            <a:ext cx="3108960" cy="430000"/>
+          </a:xfrm>
+          <a:prstGeom prst="roundRect">
+            <a:avLst>
+              <a:gd name="adj" fmla="val 16667"/>
+            </a:avLst>
+          </a:prstGeom>
+          <a:solidFill>
+            <a:srgbClr val="E6F5F2"/>
+          </a:solidFill>
+          <a:ln w="12700">
+            <a:solidFill>
+              <a:srgbClr val="0F9D8F"/>
+            </a:solidFill>
+          </a:ln>
+          <a:effectLst/>
+        </p:spPr>
+        <p:style>
+          <a:lnRef idx="1">
+            <a:schemeClr val="accent1"/>
+          </a:lnRef>
+          <a:fillRef idx="3">
+            <a:schemeClr val="accent1"/>
+          </a:fillRef>
+          <a:effectRef idx="2">
+            <a:schemeClr val="accent1"/>
+          </a:effectRef>
+          <a:fontRef idx="minor">
+            <a:schemeClr val="lt1"/>
+          </a:fontRef>
+        </p:style>
+        <p:txBody>
+          <a:bodyPr rtlCol="0" anchor="ctr" wrap="square" lIns="14000" rIns="14000" tIns="14000" bIns="14000"/>
+          <a:lstStyle/>
+          <a:p>
+            <a:pPr algn="ctr"/>
+            <a:r>
+              <a:rPr sz="1050" b="1">
+                <a:solidFill>
+                  <a:srgbClr val="0F9D8F"/>
+                </a:solidFill>
+                <a:latin typeface="Arial"/>
+              </a:rPr>
+              <a:t>DB 분석 · 차트 선택</a:t>
+            </a:r>
+          </a:p>
+          <a:p>
+            <a:pPr algn="ctr"/>
+            <a:r>
+              <a:rPr sz="950">
+                <a:solidFill>
+                  <a:srgbClr val="1C2E45"/>
+                </a:solidFill>
+                <a:latin typeface="Arial"/>
+              </a:rPr>
+              <a:t>scatter · box · pie · histogram</a:t>
+            </a:r>
+          </a:p>
+        </p:txBody>
+      </p:sp>
+      <p:sp>
+        <p:nvSpPr>
+          <p:cNvPr id="31" name="TextBox 30"/>
+          <p:cNvSpPr txBox="1"/>
+          <p:nvPr/>
+        </p:nvSpPr>
+        <p:spPr>
+          <a:xfrm>
+            <a:off x="4837760" y="4532000"/>
+            <a:ext cx="200000" cy="110000"/>
+          </a:xfrm>
+          <a:prstGeom prst="rect">
+            <a:avLst/>
+          </a:prstGeom>
+          <a:noFill/>
+        </p:spPr>
+        <p:txBody>
+          <a:bodyPr wrap="none" lIns="0" rIns="0" tIns="0" bIns="0" anchor="ctr">
+            <a:spAutoFit/>
+          </a:bodyPr>
+          <a:lstStyle/>
+          <a:p>
+            <a:pPr algn="ctr"/>
+            <a:r>
+              <a:rPr sz="800">
+                <a:solidFill>
+                  <a:srgbClr val="0F9D8F"/>
+                </a:solidFill>
+                <a:latin typeface="Arial"/>
+              </a:rPr>
+              <a:t>▼</a:t>
+            </a:r>
           </a:p>
         </p:txBody>
       </p:sp>

</xml_diff>

<commit_message>
Restructure frontend to sidebar workspace (EOM 변환 / DB 분석)
EOM_Agent_Frontend 설계 반영 + 잘못 추가된 Overview PPT box 원복.

Frontend:
- base.html: 좌측 다크 사이드바 셸(EOM Agent / WORKSPACE / EOM 변환·DB 분석 /
  Agent online) + 라이트 워크스페이스, nav active 하이라이트
- convert.html (SCREEN 01 · EOM 변환): 업로드 드롭존 + 파싱모델 + 출력형식(JSON/CSV)
  + Eye·Margin 결과/에러 프리뷰
- analysis.html (SCREEN 02 · DB 분석): 검색/필터 + 결과 테이블 +
  차트 4종 선택(scatter/box/pie/histogram) + KPI(평균 T-margin/Pass rate) + 내보내기
- style.css: 사이드바 워크스페이스(라이트 콘텐츠/다크 사이드바, 딥틸 포인트)로 개편
- main.py: 라우트 재구성 /→/convert, /convert(GET·POST), /analysis,
  /analysis/export(CSV), /upload·/results 하위호환 리다이렉트
- 구 템플릿(index/upload/results.html) 제거

PPT: Overview 슬라이드 3의 잘못된 'DB 분석 box' 원복.

검증: 템플릿 렌더(3케이스+차트셀렉터), main.py 컴파일, db_queries seed 테스트 통과.

Co-Authored-By: Claude Opus 4.8 <noreply@anthropic.com>
Claude-Session: https://claude.ai/code/session_017j13vZbd8GoEdjrSJmwL2Z
</commit_message>
<xml_diff>
--- a/eom_analyzer/docs/PAM4_EOM_Agent_Overview.pptx
+++ b/eom_analyzer/docs/PAM4_EOM_Agent_Overview.pptx
@@ -4718,110 +4718,6 @@
               <a:t>created_at</a:t>
             </a:r>
             <a:endParaRPr lang="en-US" sz="950" dirty="0"/>
-          </a:p>
-        </p:txBody>
-      </p:sp>
-      <p:sp>
-        <p:nvSpPr>
-          <p:cNvPr id="30" name="DB Analysis Box"/>
-          <p:cNvSpPr/>
-          <p:nvPr/>
-        </p:nvSpPr>
-        <p:spPr>
-          <a:xfrm>
-            <a:off x="3383280" y="4632000"/>
-            <a:ext cx="3108960" cy="430000"/>
-          </a:xfrm>
-          <a:prstGeom prst="roundRect">
-            <a:avLst>
-              <a:gd name="adj" fmla="val 16667"/>
-            </a:avLst>
-          </a:prstGeom>
-          <a:solidFill>
-            <a:srgbClr val="E6F5F2"/>
-          </a:solidFill>
-          <a:ln w="12700">
-            <a:solidFill>
-              <a:srgbClr val="0F9D8F"/>
-            </a:solidFill>
-          </a:ln>
-          <a:effectLst/>
-        </p:spPr>
-        <p:style>
-          <a:lnRef idx="1">
-            <a:schemeClr val="accent1"/>
-          </a:lnRef>
-          <a:fillRef idx="3">
-            <a:schemeClr val="accent1"/>
-          </a:fillRef>
-          <a:effectRef idx="2">
-            <a:schemeClr val="accent1"/>
-          </a:effectRef>
-          <a:fontRef idx="minor">
-            <a:schemeClr val="lt1"/>
-          </a:fontRef>
-        </p:style>
-        <p:txBody>
-          <a:bodyPr rtlCol="0" anchor="ctr" wrap="square" lIns="14000" rIns="14000" tIns="14000" bIns="14000"/>
-          <a:lstStyle/>
-          <a:p>
-            <a:pPr algn="ctr"/>
-            <a:r>
-              <a:rPr sz="1050" b="1">
-                <a:solidFill>
-                  <a:srgbClr val="0F9D8F"/>
-                </a:solidFill>
-                <a:latin typeface="Arial"/>
-              </a:rPr>
-              <a:t>DB 분석 · 차트 선택</a:t>
-            </a:r>
-          </a:p>
-          <a:p>
-            <a:pPr algn="ctr"/>
-            <a:r>
-              <a:rPr sz="950">
-                <a:solidFill>
-                  <a:srgbClr val="1C2E45"/>
-                </a:solidFill>
-                <a:latin typeface="Arial"/>
-              </a:rPr>
-              <a:t>scatter · box · pie · histogram</a:t>
-            </a:r>
-          </a:p>
-        </p:txBody>
-      </p:sp>
-      <p:sp>
-        <p:nvSpPr>
-          <p:cNvPr id="31" name="TextBox 30"/>
-          <p:cNvSpPr txBox="1"/>
-          <p:nvPr/>
-        </p:nvSpPr>
-        <p:spPr>
-          <a:xfrm>
-            <a:off x="4837760" y="4532000"/>
-            <a:ext cx="200000" cy="110000"/>
-          </a:xfrm>
-          <a:prstGeom prst="rect">
-            <a:avLst/>
-          </a:prstGeom>
-          <a:noFill/>
-        </p:spPr>
-        <p:txBody>
-          <a:bodyPr wrap="none" lIns="0" rIns="0" tIns="0" bIns="0" anchor="ctr">
-            <a:spAutoFit/>
-          </a:bodyPr>
-          <a:lstStyle/>
-          <a:p>
-            <a:pPr algn="ctr"/>
-            <a:r>
-              <a:rPr sz="800">
-                <a:solidFill>
-                  <a:srgbClr val="0F9D8F"/>
-                </a:solidFill>
-                <a:latin typeface="Arial"/>
-              </a:rPr>
-              <a:t>▼</a:t>
-            </a:r>
           </a:p>
         </p:txBody>
       </p:sp>

</xml_diff>

<commit_message>
PPT slide 3: add DB query/chart-compare box linked from Menu 2
Frontend 레이어의 MENU 2(DB 조회/비교 차트)에서 연결되는 박스 추가:
- 'DB 조회 · 차트 비교' + 'scatter · box · pie · histogram'
- Frontend 열 하단, 패널에서 내려오는 연결 표시(▼), 딥틸 강조 테두리
- 이전에 Langflow 레이어에 잘못 넣었던 위치를 Frontend(MENU 2)로 정정
- python-pptx로 기존 서식 유지, 7개 슬라이드 보존

Co-Authored-By: Claude Opus 4.8 <noreply@anthropic.com>
Claude-Session: https://claude.ai/code/session_017j13vZbd8GoEdjrSJmwL2Z
</commit_message>
<xml_diff>
--- a/eom_analyzer/docs/PAM4_EOM_Agent_Overview.pptx
+++ b/eom_analyzer/docs/PAM4_EOM_Agent_Overview.pptx
@@ -4718,6 +4718,110 @@
               <a:t>created_at</a:t>
             </a:r>
             <a:endParaRPr lang="en-US" sz="950" dirty="0"/>
+          </a:p>
+        </p:txBody>
+      </p:sp>
+      <p:sp>
+        <p:nvSpPr>
+          <p:cNvPr id="30" name="DB Query/Chart Box (Menu2)"/>
+          <p:cNvSpPr/>
+          <p:nvPr/>
+        </p:nvSpPr>
+        <p:spPr>
+          <a:xfrm>
+            <a:off x="548640" y="4638000"/>
+            <a:ext cx="2377440" cy="430000"/>
+          </a:xfrm>
+          <a:prstGeom prst="roundRect">
+            <a:avLst>
+              <a:gd name="adj" fmla="val 16667"/>
+            </a:avLst>
+          </a:prstGeom>
+          <a:solidFill>
+            <a:srgbClr val="E6F5F2"/>
+          </a:solidFill>
+          <a:ln w="12700">
+            <a:solidFill>
+              <a:srgbClr val="0F9D8F"/>
+            </a:solidFill>
+          </a:ln>
+          <a:effectLst/>
+        </p:spPr>
+        <p:style>
+          <a:lnRef idx="1">
+            <a:schemeClr val="accent1"/>
+          </a:lnRef>
+          <a:fillRef idx="3">
+            <a:schemeClr val="accent1"/>
+          </a:fillRef>
+          <a:effectRef idx="2">
+            <a:schemeClr val="accent1"/>
+          </a:effectRef>
+          <a:fontRef idx="minor">
+            <a:schemeClr val="lt1"/>
+          </a:fontRef>
+        </p:style>
+        <p:txBody>
+          <a:bodyPr rtlCol="0" anchor="ctr" wrap="square" lIns="12000" rIns="12000" tIns="12000" bIns="12000"/>
+          <a:lstStyle/>
+          <a:p>
+            <a:pPr algn="ctr"/>
+            <a:r>
+              <a:rPr sz="1050" b="1">
+                <a:solidFill>
+                  <a:srgbClr val="0F9D8F"/>
+                </a:solidFill>
+                <a:latin typeface="Arial"/>
+              </a:rPr>
+              <a:t>DB 조회 · 차트 비교</a:t>
+            </a:r>
+          </a:p>
+          <a:p>
+            <a:pPr algn="ctr"/>
+            <a:r>
+              <a:rPr sz="950">
+                <a:solidFill>
+                  <a:srgbClr val="1C2E45"/>
+                </a:solidFill>
+                <a:latin typeface="Arial"/>
+              </a:rPr>
+              <a:t>scatter · box · pie · histogram</a:t>
+            </a:r>
+          </a:p>
+        </p:txBody>
+      </p:sp>
+      <p:sp>
+        <p:nvSpPr>
+          <p:cNvPr id="31" name="TextBox 30"/>
+          <p:cNvSpPr txBox="1"/>
+          <p:nvPr/>
+        </p:nvSpPr>
+        <p:spPr>
+          <a:xfrm>
+            <a:off x="1637360" y="4532000"/>
+            <a:ext cx="200000" cy="110000"/>
+          </a:xfrm>
+          <a:prstGeom prst="rect">
+            <a:avLst/>
+          </a:prstGeom>
+          <a:noFill/>
+        </p:spPr>
+        <p:txBody>
+          <a:bodyPr wrap="none" lIns="0" rIns="0" tIns="0" bIns="0" anchor="ctr">
+            <a:spAutoFit/>
+          </a:bodyPr>
+          <a:lstStyle/>
+          <a:p>
+            <a:pPr algn="ctr"/>
+            <a:r>
+              <a:rPr sz="800">
+                <a:solidFill>
+                  <a:srgbClr val="0F9D8F"/>
+                </a:solidFill>
+                <a:latin typeface="Arial"/>
+              </a:rPr>
+              <a:t>▼</a:t>
+            </a:r>
           </a:p>
         </p:txBody>
       </p:sp>

</xml_diff>